<commit_message>
Disable anonymization — show first name + LAST NAME
- Sidebar top affiche désormais "Prénom" en normal + "NOM" en gras
  majuscules à la place des initiales (matches the Alexandre CV
  template style).
- Initiales conservées comme fallback si first_name et last_name
  sont vides (permet de ré-activer l'anonymisation cas par cas).
- FS_FIRST_NAME = 28pt regular, FS_LAST_NAME = 32pt bold uppercase.
- Système prompt mis à jour : anonymisation optionnelle, plus par
  défaut. Toutes les autres règles (adresse, email, téléphone,
  date de naissance, LinkedIn, photo, genre) restent supprimées.

Co-Authored-By: Claude Opus 4.7 <noreply@anthropic.com>
Claude-Session: https://claude.ai/code/session_01P34Y9PqaSyqWxj7EA7cQyd
</commit_message>
<xml_diff>
--- a/outputs/all_cvs.pptx
+++ b/outputs/all_cvs.pptx
@@ -3221,8 +3221,8 @@
         </p:nvSpPr>
         <p:spPr>
           <a:xfrm>
-            <a:off x="228600" y="260000"/>
-            <a:ext cx="3842800" cy="800000"/>
+            <a:off x="228600" y="240000"/>
+            <a:ext cx="3842800" cy="1300000"/>
           </a:xfrm>
           <a:prstGeom prst="rect">
             <a:avLst/>
@@ -3237,13 +3237,29 @@
           <a:p>
             <a:pPr algn="l"/>
             <a:r>
-              <a:rPr sz="4800" b="1" i="0">
-                <a:solidFill>
-                  <a:srgbClr val="3AEDE5"/>
-                </a:solidFill>
-                <a:latin typeface="Alegreya Sans"/>
-              </a:rPr>
-              <a:t>A.P.</a:t>
+              <a:rPr sz="2800" b="0" i="0">
+                <a:solidFill>
+                  <a:srgbClr val="3AEDE5"/>
+                </a:solidFill>
+                <a:latin typeface="Alegreya Sans"/>
+              </a:rPr>
+              <a:t>Alexandre</a:t>
+            </a:r>
+          </a:p>
+          <a:p>
+            <a:pPr>
+              <a:spcBef>
+                <a:spcPts val="0"/>
+              </a:spcBef>
+            </a:pPr>
+            <a:r>
+              <a:rPr sz="3200" b="1" i="0">
+                <a:solidFill>
+                  <a:srgbClr val="3AEDE5"/>
+                </a:solidFill>
+                <a:latin typeface="Alegreya Sans"/>
+              </a:rPr>
+              <a:t>POLAKOWSKI</a:t>
             </a:r>
           </a:p>
         </p:txBody>
@@ -4430,8 +4446,8 @@
         </p:nvSpPr>
         <p:spPr>
           <a:xfrm>
-            <a:off x="228600" y="260000"/>
-            <a:ext cx="3842800" cy="800000"/>
+            <a:off x="228600" y="240000"/>
+            <a:ext cx="3842800" cy="1300000"/>
           </a:xfrm>
           <a:prstGeom prst="rect">
             <a:avLst/>
@@ -4446,13 +4462,29 @@
           <a:p>
             <a:pPr algn="l"/>
             <a:r>
-              <a:rPr sz="4800" b="1" i="0">
-                <a:solidFill>
-                  <a:srgbClr val="3AEDE5"/>
-                </a:solidFill>
-                <a:latin typeface="Alegreya Sans"/>
-              </a:rPr>
-              <a:t>D.L.</a:t>
+              <a:rPr sz="2800" b="0" i="0">
+                <a:solidFill>
+                  <a:srgbClr val="3AEDE5"/>
+                </a:solidFill>
+                <a:latin typeface="Alegreya Sans"/>
+              </a:rPr>
+              <a:t>David</a:t>
+            </a:r>
+          </a:p>
+          <a:p>
+            <a:pPr>
+              <a:spcBef>
+                <a:spcPts val="0"/>
+              </a:spcBef>
+            </a:pPr>
+            <a:r>
+              <a:rPr sz="3200" b="1" i="0">
+                <a:solidFill>
+                  <a:srgbClr val="3AEDE5"/>
+                </a:solidFill>
+                <a:latin typeface="Alegreya Sans"/>
+              </a:rPr>
+              <a:t>LECLERCQ</a:t>
             </a:r>
           </a:p>
         </p:txBody>
@@ -5586,8 +5618,8 @@
         </p:nvSpPr>
         <p:spPr>
           <a:xfrm>
-            <a:off x="228600" y="260000"/>
-            <a:ext cx="3842800" cy="800000"/>
+            <a:off x="228600" y="240000"/>
+            <a:ext cx="3842800" cy="1300000"/>
           </a:xfrm>
           <a:prstGeom prst="rect">
             <a:avLst/>
@@ -5602,13 +5634,29 @@
           <a:p>
             <a:pPr algn="l"/>
             <a:r>
-              <a:rPr sz="4800" b="1" i="0">
-                <a:solidFill>
-                  <a:srgbClr val="3AEDE5"/>
-                </a:solidFill>
-                <a:latin typeface="Alegreya Sans"/>
-              </a:rPr>
-              <a:t>I.D.</a:t>
+              <a:rPr sz="2800" b="0" i="0">
+                <a:solidFill>
+                  <a:srgbClr val="3AEDE5"/>
+                </a:solidFill>
+                <a:latin typeface="Alegreya Sans"/>
+              </a:rPr>
+              <a:t>Ingrid</a:t>
+            </a:r>
+          </a:p>
+          <a:p>
+            <a:pPr>
+              <a:spcBef>
+                <a:spcPts val="0"/>
+              </a:spcBef>
+            </a:pPr>
+            <a:r>
+              <a:rPr sz="3200" b="1" i="0">
+                <a:solidFill>
+                  <a:srgbClr val="3AEDE5"/>
+                </a:solidFill>
+                <a:latin typeface="Alegreya Sans"/>
+              </a:rPr>
+              <a:t>DAKITSE</a:t>
             </a:r>
           </a:p>
         </p:txBody>
@@ -6642,8 +6690,8 @@
         </p:nvSpPr>
         <p:spPr>
           <a:xfrm>
-            <a:off x="228600" y="260000"/>
-            <a:ext cx="3842800" cy="800000"/>
+            <a:off x="228600" y="240000"/>
+            <a:ext cx="3842800" cy="1300000"/>
           </a:xfrm>
           <a:prstGeom prst="rect">
             <a:avLst/>
@@ -6658,13 +6706,29 @@
           <a:p>
             <a:pPr algn="l"/>
             <a:r>
-              <a:rPr sz="4800" b="1" i="0">
-                <a:solidFill>
-                  <a:srgbClr val="3AEDE5"/>
-                </a:solidFill>
-                <a:latin typeface="Alegreya Sans"/>
-              </a:rPr>
-              <a:t>I.D.</a:t>
+              <a:rPr sz="2800" b="0" i="0">
+                <a:solidFill>
+                  <a:srgbClr val="3AEDE5"/>
+                </a:solidFill>
+                <a:latin typeface="Alegreya Sans"/>
+              </a:rPr>
+              <a:t>Ingrid</a:t>
+            </a:r>
+          </a:p>
+          <a:p>
+            <a:pPr>
+              <a:spcBef>
+                <a:spcPts val="0"/>
+              </a:spcBef>
+            </a:pPr>
+            <a:r>
+              <a:rPr sz="3200" b="1" i="0">
+                <a:solidFill>
+                  <a:srgbClr val="3AEDE5"/>
+                </a:solidFill>
+                <a:latin typeface="Alegreya Sans"/>
+              </a:rPr>
+              <a:t>DAKITSE</a:t>
             </a:r>
           </a:p>
         </p:txBody>
@@ -7698,8 +7762,8 @@
         </p:nvSpPr>
         <p:spPr>
           <a:xfrm>
-            <a:off x="228600" y="260000"/>
-            <a:ext cx="3842800" cy="800000"/>
+            <a:off x="228600" y="240000"/>
+            <a:ext cx="3842800" cy="1300000"/>
           </a:xfrm>
           <a:prstGeom prst="rect">
             <a:avLst/>
@@ -7714,13 +7778,29 @@
           <a:p>
             <a:pPr algn="l"/>
             <a:r>
-              <a:rPr sz="4800" b="1" i="0">
-                <a:solidFill>
-                  <a:srgbClr val="3AEDE5"/>
-                </a:solidFill>
-                <a:latin typeface="Alegreya Sans"/>
-              </a:rPr>
-              <a:t>R.M.</a:t>
+              <a:rPr sz="2800" b="0" i="0">
+                <a:solidFill>
+                  <a:srgbClr val="3AEDE5"/>
+                </a:solidFill>
+                <a:latin typeface="Alegreya Sans"/>
+              </a:rPr>
+              <a:t>Richard</a:t>
+            </a:r>
+          </a:p>
+          <a:p>
+            <a:pPr>
+              <a:spcBef>
+                <a:spcPts val="0"/>
+              </a:spcBef>
+            </a:pPr>
+            <a:r>
+              <a:rPr sz="3200" b="1" i="0">
+                <a:solidFill>
+                  <a:srgbClr val="3AEDE5"/>
+                </a:solidFill>
+                <a:latin typeface="Alegreya Sans"/>
+              </a:rPr>
+              <a:t>MICHAUD</a:t>
             </a:r>
           </a:p>
         </p:txBody>
@@ -8934,8 +9014,8 @@
         </p:nvSpPr>
         <p:spPr>
           <a:xfrm>
-            <a:off x="228600" y="260000"/>
-            <a:ext cx="3842800" cy="800000"/>
+            <a:off x="228600" y="240000"/>
+            <a:ext cx="3842800" cy="1300000"/>
           </a:xfrm>
           <a:prstGeom prst="rect">
             <a:avLst/>
@@ -8950,13 +9030,29 @@
           <a:p>
             <a:pPr algn="l"/>
             <a:r>
-              <a:rPr sz="4800" b="1" i="0">
-                <a:solidFill>
-                  <a:srgbClr val="3AEDE5"/>
-                </a:solidFill>
-                <a:latin typeface="Alegreya Sans"/>
-              </a:rPr>
-              <a:t>R.M.</a:t>
+              <a:rPr sz="2800" b="0" i="0">
+                <a:solidFill>
+                  <a:srgbClr val="3AEDE5"/>
+                </a:solidFill>
+                <a:latin typeface="Alegreya Sans"/>
+              </a:rPr>
+              <a:t>Richard</a:t>
+            </a:r>
+          </a:p>
+          <a:p>
+            <a:pPr>
+              <a:spcBef>
+                <a:spcPts val="0"/>
+              </a:spcBef>
+            </a:pPr>
+            <a:r>
+              <a:rPr sz="3200" b="1" i="0">
+                <a:solidFill>
+                  <a:srgbClr val="3AEDE5"/>
+                </a:solidFill>
+                <a:latin typeface="Alegreya Sans"/>
+              </a:rPr>
+              <a:t>MICHAUD</a:t>
             </a:r>
           </a:p>
         </p:txBody>
@@ -10170,8 +10266,8 @@
         </p:nvSpPr>
         <p:spPr>
           <a:xfrm>
-            <a:off x="228600" y="260000"/>
-            <a:ext cx="3842800" cy="800000"/>
+            <a:off x="228600" y="240000"/>
+            <a:ext cx="3842800" cy="1300000"/>
           </a:xfrm>
           <a:prstGeom prst="rect">
             <a:avLst/>
@@ -10186,13 +10282,29 @@
           <a:p>
             <a:pPr algn="l"/>
             <a:r>
-              <a:rPr sz="4800" b="1" i="0">
-                <a:solidFill>
-                  <a:srgbClr val="3AEDE5"/>
-                </a:solidFill>
-                <a:latin typeface="Alegreya Sans"/>
-              </a:rPr>
-              <a:t>A.P.</a:t>
+              <a:rPr sz="2800" b="0" i="0">
+                <a:solidFill>
+                  <a:srgbClr val="3AEDE5"/>
+                </a:solidFill>
+                <a:latin typeface="Alegreya Sans"/>
+              </a:rPr>
+              <a:t>Alexandre</a:t>
+            </a:r>
+          </a:p>
+          <a:p>
+            <a:pPr>
+              <a:spcBef>
+                <a:spcPts val="0"/>
+              </a:spcBef>
+            </a:pPr>
+            <a:r>
+              <a:rPr sz="3200" b="1" i="0">
+                <a:solidFill>
+                  <a:srgbClr val="3AEDE5"/>
+                </a:solidFill>
+                <a:latin typeface="Alegreya Sans"/>
+              </a:rPr>
+              <a:t>POLAKOWSKI</a:t>
             </a:r>
           </a:p>
         </p:txBody>
@@ -11379,8 +11491,8 @@
         </p:nvSpPr>
         <p:spPr>
           <a:xfrm>
-            <a:off x="228600" y="260000"/>
-            <a:ext cx="3842800" cy="800000"/>
+            <a:off x="228600" y="240000"/>
+            <a:ext cx="3842800" cy="1300000"/>
           </a:xfrm>
           <a:prstGeom prst="rect">
             <a:avLst/>
@@ -11395,13 +11507,29 @@
           <a:p>
             <a:pPr algn="l"/>
             <a:r>
-              <a:rPr sz="4800" b="1" i="0">
-                <a:solidFill>
-                  <a:srgbClr val="3AEDE5"/>
-                </a:solidFill>
-                <a:latin typeface="Alegreya Sans"/>
-              </a:rPr>
-              <a:t>C.C.</a:t>
+              <a:rPr sz="2800" b="0" i="0">
+                <a:solidFill>
+                  <a:srgbClr val="3AEDE5"/>
+                </a:solidFill>
+                <a:latin typeface="Alegreya Sans"/>
+              </a:rPr>
+              <a:t>Célia</a:t>
+            </a:r>
+          </a:p>
+          <a:p>
+            <a:pPr>
+              <a:spcBef>
+                <a:spcPts val="0"/>
+              </a:spcBef>
+            </a:pPr>
+            <a:r>
+              <a:rPr sz="3200" b="1" i="0">
+                <a:solidFill>
+                  <a:srgbClr val="3AEDE5"/>
+                </a:solidFill>
+                <a:latin typeface="Alegreya Sans"/>
+              </a:rPr>
+              <a:t>CORVISIER</a:t>
             </a:r>
           </a:p>
         </p:txBody>
@@ -12588,8 +12716,8 @@
         </p:nvSpPr>
         <p:spPr>
           <a:xfrm>
-            <a:off x="228600" y="260000"/>
-            <a:ext cx="3842800" cy="800000"/>
+            <a:off x="228600" y="240000"/>
+            <a:ext cx="3842800" cy="1300000"/>
           </a:xfrm>
           <a:prstGeom prst="rect">
             <a:avLst/>
@@ -12604,13 +12732,29 @@
           <a:p>
             <a:pPr algn="l"/>
             <a:r>
-              <a:rPr sz="4800" b="1" i="0">
-                <a:solidFill>
-                  <a:srgbClr val="3AEDE5"/>
-                </a:solidFill>
-                <a:latin typeface="Alegreya Sans"/>
-              </a:rPr>
-              <a:t>C.C.</a:t>
+              <a:rPr sz="2800" b="0" i="0">
+                <a:solidFill>
+                  <a:srgbClr val="3AEDE5"/>
+                </a:solidFill>
+                <a:latin typeface="Alegreya Sans"/>
+              </a:rPr>
+              <a:t>Célia</a:t>
+            </a:r>
+          </a:p>
+          <a:p>
+            <a:pPr>
+              <a:spcBef>
+                <a:spcPts val="0"/>
+              </a:spcBef>
+            </a:pPr>
+            <a:r>
+              <a:rPr sz="3200" b="1" i="0">
+                <a:solidFill>
+                  <a:srgbClr val="3AEDE5"/>
+                </a:solidFill>
+                <a:latin typeface="Alegreya Sans"/>
+              </a:rPr>
+              <a:t>CORVISIER</a:t>
             </a:r>
           </a:p>
         </p:txBody>
@@ -13797,8 +13941,8 @@
         </p:nvSpPr>
         <p:spPr>
           <a:xfrm>
-            <a:off x="228600" y="260000"/>
-            <a:ext cx="3842800" cy="800000"/>
+            <a:off x="228600" y="240000"/>
+            <a:ext cx="3842800" cy="1300000"/>
           </a:xfrm>
           <a:prstGeom prst="rect">
             <a:avLst/>
@@ -13813,13 +13957,29 @@
           <a:p>
             <a:pPr algn="l"/>
             <a:r>
-              <a:rPr sz="4800" b="1" i="0">
-                <a:solidFill>
-                  <a:srgbClr val="3AEDE5"/>
-                </a:solidFill>
-                <a:latin typeface="Alegreya Sans"/>
-              </a:rPr>
-              <a:t>C.H.</a:t>
+              <a:rPr sz="2800" b="0" i="0">
+                <a:solidFill>
+                  <a:srgbClr val="3AEDE5"/>
+                </a:solidFill>
+                <a:latin typeface="Alegreya Sans"/>
+              </a:rPr>
+              <a:t>Célia</a:t>
+            </a:r>
+          </a:p>
+          <a:p>
+            <a:pPr>
+              <a:spcBef>
+                <a:spcPts val="0"/>
+              </a:spcBef>
+            </a:pPr>
+            <a:r>
+              <a:rPr sz="3200" b="1" i="0">
+                <a:solidFill>
+                  <a:srgbClr val="3AEDE5"/>
+                </a:solidFill>
+                <a:latin typeface="Alegreya Sans"/>
+              </a:rPr>
+              <a:t>HAMMAR</a:t>
             </a:r>
           </a:p>
         </p:txBody>
@@ -14887,8 +15047,8 @@
         </p:nvSpPr>
         <p:spPr>
           <a:xfrm>
-            <a:off x="228600" y="260000"/>
-            <a:ext cx="3842800" cy="800000"/>
+            <a:off x="228600" y="240000"/>
+            <a:ext cx="3842800" cy="1300000"/>
           </a:xfrm>
           <a:prstGeom prst="rect">
             <a:avLst/>
@@ -14903,13 +15063,29 @@
           <a:p>
             <a:pPr algn="l"/>
             <a:r>
-              <a:rPr sz="4800" b="1" i="0">
-                <a:solidFill>
-                  <a:srgbClr val="3AEDE5"/>
-                </a:solidFill>
-                <a:latin typeface="Alegreya Sans"/>
-              </a:rPr>
-              <a:t>C.H.</a:t>
+              <a:rPr sz="2800" b="0" i="0">
+                <a:solidFill>
+                  <a:srgbClr val="3AEDE5"/>
+                </a:solidFill>
+                <a:latin typeface="Alegreya Sans"/>
+              </a:rPr>
+              <a:t>Célia</a:t>
+            </a:r>
+          </a:p>
+          <a:p>
+            <a:pPr>
+              <a:spcBef>
+                <a:spcPts val="0"/>
+              </a:spcBef>
+            </a:pPr>
+            <a:r>
+              <a:rPr sz="3200" b="1" i="0">
+                <a:solidFill>
+                  <a:srgbClr val="3AEDE5"/>
+                </a:solidFill>
+                <a:latin typeface="Alegreya Sans"/>
+              </a:rPr>
+              <a:t>HAMMAR</a:t>
             </a:r>
           </a:p>
         </p:txBody>
@@ -15977,8 +16153,8 @@
         </p:nvSpPr>
         <p:spPr>
           <a:xfrm>
-            <a:off x="228600" y="260000"/>
-            <a:ext cx="3842800" cy="800000"/>
+            <a:off x="228600" y="240000"/>
+            <a:ext cx="3842800" cy="1300000"/>
           </a:xfrm>
           <a:prstGeom prst="rect">
             <a:avLst/>
@@ -15993,13 +16169,29 @@
           <a:p>
             <a:pPr algn="l"/>
             <a:r>
-              <a:rPr sz="4800" b="1" i="0">
-                <a:solidFill>
-                  <a:srgbClr val="3AEDE5"/>
-                </a:solidFill>
-                <a:latin typeface="Alegreya Sans"/>
-              </a:rPr>
-              <a:t>C.P.</a:t>
+              <a:rPr sz="2800" b="0" i="0">
+                <a:solidFill>
+                  <a:srgbClr val="3AEDE5"/>
+                </a:solidFill>
+                <a:latin typeface="Alegreya Sans"/>
+              </a:rPr>
+              <a:t>Christophe</a:t>
+            </a:r>
+          </a:p>
+          <a:p>
+            <a:pPr>
+              <a:spcBef>
+                <a:spcPts val="0"/>
+              </a:spcBef>
+            </a:pPr>
+            <a:r>
+              <a:rPr sz="3200" b="1" i="0">
+                <a:solidFill>
+                  <a:srgbClr val="3AEDE5"/>
+                </a:solidFill>
+                <a:latin typeface="Alegreya Sans"/>
+              </a:rPr>
+              <a:t>POBEREJSKY</a:t>
             </a:r>
           </a:p>
         </p:txBody>
@@ -17204,8 +17396,8 @@
         </p:nvSpPr>
         <p:spPr>
           <a:xfrm>
-            <a:off x="228600" y="260000"/>
-            <a:ext cx="3842800" cy="800000"/>
+            <a:off x="228600" y="240000"/>
+            <a:ext cx="3842800" cy="1300000"/>
           </a:xfrm>
           <a:prstGeom prst="rect">
             <a:avLst/>
@@ -17220,13 +17412,29 @@
           <a:p>
             <a:pPr algn="l"/>
             <a:r>
-              <a:rPr sz="4800" b="1" i="0">
-                <a:solidFill>
-                  <a:srgbClr val="3AEDE5"/>
-                </a:solidFill>
-                <a:latin typeface="Alegreya Sans"/>
-              </a:rPr>
-              <a:t>C.P.</a:t>
+              <a:rPr sz="2800" b="0" i="0">
+                <a:solidFill>
+                  <a:srgbClr val="3AEDE5"/>
+                </a:solidFill>
+                <a:latin typeface="Alegreya Sans"/>
+              </a:rPr>
+              <a:t>Christophe</a:t>
+            </a:r>
+          </a:p>
+          <a:p>
+            <a:pPr>
+              <a:spcBef>
+                <a:spcPts val="0"/>
+              </a:spcBef>
+            </a:pPr>
+            <a:r>
+              <a:rPr sz="3200" b="1" i="0">
+                <a:solidFill>
+                  <a:srgbClr val="3AEDE5"/>
+                </a:solidFill>
+                <a:latin typeface="Alegreya Sans"/>
+              </a:rPr>
+              <a:t>POBEREJSKY</a:t>
             </a:r>
           </a:p>
         </p:txBody>
@@ -18431,8 +18639,8 @@
         </p:nvSpPr>
         <p:spPr>
           <a:xfrm>
-            <a:off x="228600" y="260000"/>
-            <a:ext cx="3842800" cy="800000"/>
+            <a:off x="228600" y="240000"/>
+            <a:ext cx="3842800" cy="1300000"/>
           </a:xfrm>
           <a:prstGeom prst="rect">
             <a:avLst/>
@@ -18447,13 +18655,29 @@
           <a:p>
             <a:pPr algn="l"/>
             <a:r>
-              <a:rPr sz="4800" b="1" i="0">
-                <a:solidFill>
-                  <a:srgbClr val="3AEDE5"/>
-                </a:solidFill>
-                <a:latin typeface="Alegreya Sans"/>
-              </a:rPr>
-              <a:t>D.L.</a:t>
+              <a:rPr sz="2800" b="0" i="0">
+                <a:solidFill>
+                  <a:srgbClr val="3AEDE5"/>
+                </a:solidFill>
+                <a:latin typeface="Alegreya Sans"/>
+              </a:rPr>
+              <a:t>David</a:t>
+            </a:r>
+          </a:p>
+          <a:p>
+            <a:pPr>
+              <a:spcBef>
+                <a:spcPts val="0"/>
+              </a:spcBef>
+            </a:pPr>
+            <a:r>
+              <a:rPr sz="3200" b="1" i="0">
+                <a:solidFill>
+                  <a:srgbClr val="3AEDE5"/>
+                </a:solidFill>
+                <a:latin typeface="Alegreya Sans"/>
+              </a:rPr>
+              <a:t>LECLERCQ</a:t>
             </a:r>
           </a:p>
         </p:txBody>

</xml_diff>